<commit_message>
Connect care access, outdoor prevention and county action in demo narrative
</commit_message>
<xml_diff>
--- a/submission/PathwayAI_Patient_First_Demo_Slides.pptx
+++ b/submission/PathwayAI_Patient_First_Demo_Slides.pptx
@@ -18,6 +18,8 @@
     <p:sldId id="266" r:id="rId17"/>
     <p:sldId id="267" r:id="rId18"/>
     <p:sldId id="268" r:id="rId19"/>
+    <p:sldId id="269" r:id="rId20"/>
+    <p:sldId id="270" r:id="rId21"/>
   </p:sldIdLst>
   <p:sldSz cx="12191999" cy="6858000" type="screen4x3"/>
   <p:notesSz cx="6858000" cy="9144000"/>
@@ -3144,7 +3146,7 @@
       <p:grpSpPr/>
       <p:pic>
         <p:nvPicPr>
-          <p:cNvPr id="2" name="Picture 1" descr="07_Community_Action.png"/>
+          <p:cNvPr id="2" name="Picture 1" descr="Optional_B_Section_Title.png"/>
           <p:cNvPicPr>
             <a:picLocks noChangeAspect="1"/>
           </p:cNvPicPr>
@@ -3186,7 +3188,7 @@
       <p:grpSpPr/>
       <p:pic>
         <p:nvPicPr>
-          <p:cNvPr id="2" name="Picture 1" descr="08_Pilot_Evaluation.png"/>
+          <p:cNvPr id="2" name="Picture 1" descr="08_County_Evidence.png"/>
           <p:cNvPicPr>
             <a:picLocks noChangeAspect="1"/>
           </p:cNvPicPr>
@@ -3228,7 +3230,7 @@
       <p:grpSpPr/>
       <p:pic>
         <p:nvPicPr>
-          <p:cNvPr id="2" name="Picture 1" descr="09_Next_Steps.png"/>
+          <p:cNvPr id="2" name="Picture 1" descr="09_Community_Action.png"/>
           <p:cNvPicPr>
             <a:picLocks noChangeAspect="1"/>
           </p:cNvPicPr>
@@ -3270,7 +3272,91 @@
       <p:grpSpPr/>
       <p:pic>
         <p:nvPicPr>
-          <p:cNvPr id="2" name="Picture 1" descr="10_Closing_And_Partners.png"/>
+          <p:cNvPr id="2" name="Picture 1" descr="10_Pilot_Evaluation.png"/>
+          <p:cNvPicPr>
+            <a:picLocks noChangeAspect="1"/>
+          </p:cNvPicPr>
+          <p:nvPr/>
+        </p:nvPicPr>
+        <p:blipFill>
+          <a:blip r:embed="rId2"/>
+          <a:stretch>
+            <a:fillRect/>
+          </a:stretch>
+        </p:blipFill>
+        <p:spPr>
+          <a:xfrm>
+            <a:off x="0" y="0"/>
+            <a:ext cx="12191999" cy="6858000"/>
+          </a:xfrm>
+          <a:prstGeom prst="rect">
+            <a:avLst/>
+          </a:prstGeom>
+        </p:spPr>
+      </p:pic>
+    </p:spTree>
+  </p:cSld>
+  <p:clrMapOvr>
+    <a:masterClrMapping/>
+  </p:clrMapOvr>
+</p:sld>
+</file>
+
+<file path=ppt/slides/slide14.xml><?xml version="1.0" encoding="utf-8"?>
+<p:sld xmlns:a="http://schemas.openxmlformats.org/drawingml/2006/main" xmlns:p="http://schemas.openxmlformats.org/presentationml/2006/main" xmlns:r="http://schemas.openxmlformats.org/officeDocument/2006/relationships">
+  <p:cSld>
+    <p:spTree>
+      <p:nvGrpSpPr>
+        <p:cNvPr id="1" name=""/>
+        <p:cNvGrpSpPr/>
+        <p:nvPr/>
+      </p:nvGrpSpPr>
+      <p:grpSpPr/>
+      <p:pic>
+        <p:nvPicPr>
+          <p:cNvPr id="2" name="Picture 1" descr="11_Next_Steps.png"/>
+          <p:cNvPicPr>
+            <a:picLocks noChangeAspect="1"/>
+          </p:cNvPicPr>
+          <p:nvPr/>
+        </p:nvPicPr>
+        <p:blipFill>
+          <a:blip r:embed="rId2"/>
+          <a:stretch>
+            <a:fillRect/>
+          </a:stretch>
+        </p:blipFill>
+        <p:spPr>
+          <a:xfrm>
+            <a:off x="0" y="0"/>
+            <a:ext cx="12191999" cy="6858000"/>
+          </a:xfrm>
+          <a:prstGeom prst="rect">
+            <a:avLst/>
+          </a:prstGeom>
+        </p:spPr>
+      </p:pic>
+    </p:spTree>
+  </p:cSld>
+  <p:clrMapOvr>
+    <a:masterClrMapping/>
+  </p:clrMapOvr>
+</p:sld>
+</file>
+
+<file path=ppt/slides/slide15.xml><?xml version="1.0" encoding="utf-8"?>
+<p:sld xmlns:a="http://schemas.openxmlformats.org/drawingml/2006/main" xmlns:p="http://schemas.openxmlformats.org/presentationml/2006/main" xmlns:r="http://schemas.openxmlformats.org/officeDocument/2006/relationships">
+  <p:cSld>
+    <p:spTree>
+      <p:nvGrpSpPr>
+        <p:cNvPr id="1" name=""/>
+        <p:cNvGrpSpPr/>
+        <p:nvPr/>
+      </p:nvGrpSpPr>
+      <p:grpSpPr/>
+      <p:pic>
+        <p:nvPicPr>
+          <p:cNvPr id="2" name="Picture 1" descr="12_Closing_And_Partners.png"/>
           <p:cNvPicPr>
             <a:picLocks noChangeAspect="1"/>
           </p:cNvPicPr>
@@ -3480,7 +3566,7 @@
       <p:grpSpPr/>
       <p:pic>
         <p:nvPicPr>
-          <p:cNvPr id="2" name="Picture 1" descr="04_Visit_And_Language.png"/>
+          <p:cNvPr id="2" name="Picture 1" descr="04_Outdoor_Plan.png"/>
           <p:cNvPicPr>
             <a:picLocks noChangeAspect="1"/>
           </p:cNvPicPr>
@@ -3522,7 +3608,7 @@
       <p:grpSpPr/>
       <p:pic>
         <p:nvPicPr>
-          <p:cNvPr id="2" name="Picture 1" descr="05_Personal_Cost_Record.png"/>
+          <p:cNvPr id="2" name="Picture 1" descr="05_After_Tick_Bite.png"/>
           <p:cNvPicPr>
             <a:picLocks noChangeAspect="1"/>
           </p:cNvPicPr>
@@ -3564,7 +3650,7 @@
       <p:grpSpPr/>
       <p:pic>
         <p:nvPicPr>
-          <p:cNvPr id="2" name="Picture 1" descr="Optional_B_Section_Title.png"/>
+          <p:cNvPr id="2" name="Picture 1" descr="06_Visit_And_Language.png"/>
           <p:cNvPicPr>
             <a:picLocks noChangeAspect="1"/>
           </p:cNvPicPr>
@@ -3606,7 +3692,7 @@
       <p:grpSpPr/>
       <p:pic>
         <p:nvPicPr>
-          <p:cNvPr id="2" name="Picture 1" descr="06_County_Evidence.png"/>
+          <p:cNvPr id="2" name="Picture 1" descr="07_Personal_Cost_Record.png"/>
           <p:cNvPicPr>
             <a:picLocks noChangeAspect="1"/>
           </p:cNvPicPr>

</xml_diff>

<commit_message>
Highlight federal open data and add language and download walkthroughs
</commit_message>
<xml_diff>
--- a/submission/PathwayAI_Patient_First_Demo_Slides.pptx
+++ b/submission/PathwayAI_Patient_First_Demo_Slides.pptx
@@ -20,6 +20,7 @@
     <p:sldId id="268" r:id="rId19"/>
     <p:sldId id="269" r:id="rId20"/>
     <p:sldId id="270" r:id="rId21"/>
+    <p:sldId id="271" r:id="rId22"/>
   </p:sldIdLst>
   <p:sldSz cx="12191999" cy="6858000" type="screen4x3"/>
   <p:notesSz cx="6858000" cy="9144000"/>
@@ -3104,7 +3105,7 @@
       <p:grpSpPr/>
       <p:pic>
         <p:nvPicPr>
-          <p:cNvPr id="2" name="Picture 1" descr="01_Personal_Story.png"/>
+          <p:cNvPr id="2" name="Picture 1" descr="image.png"/>
           <p:cNvPicPr>
             <a:picLocks noChangeAspect="1"/>
           </p:cNvPicPr>
@@ -3146,7 +3147,7 @@
       <p:grpSpPr/>
       <p:pic>
         <p:nvPicPr>
-          <p:cNvPr id="2" name="Picture 1" descr="Optional_B_Section_Title.png"/>
+          <p:cNvPr id="2" name="Picture 1" descr="image.png"/>
           <p:cNvPicPr>
             <a:picLocks noChangeAspect="1"/>
           </p:cNvPicPr>
@@ -3188,7 +3189,7 @@
       <p:grpSpPr/>
       <p:pic>
         <p:nvPicPr>
-          <p:cNvPr id="2" name="Picture 1" descr="08_County_Evidence.png"/>
+          <p:cNvPr id="2" name="Picture 1" descr="image.png"/>
           <p:cNvPicPr>
             <a:picLocks noChangeAspect="1"/>
           </p:cNvPicPr>
@@ -3230,7 +3231,7 @@
       <p:grpSpPr/>
       <p:pic>
         <p:nvPicPr>
-          <p:cNvPr id="2" name="Picture 1" descr="09_Community_Action.png"/>
+          <p:cNvPr id="2" name="Picture 1" descr="image.png"/>
           <p:cNvPicPr>
             <a:picLocks noChangeAspect="1"/>
           </p:cNvPicPr>
@@ -3272,7 +3273,7 @@
       <p:grpSpPr/>
       <p:pic>
         <p:nvPicPr>
-          <p:cNvPr id="2" name="Picture 1" descr="10_Pilot_Evaluation.png"/>
+          <p:cNvPr id="2" name="Picture 1" descr="image.png"/>
           <p:cNvPicPr>
             <a:picLocks noChangeAspect="1"/>
           </p:cNvPicPr>
@@ -3314,7 +3315,7 @@
       <p:grpSpPr/>
       <p:pic>
         <p:nvPicPr>
-          <p:cNvPr id="2" name="Picture 1" descr="11_Next_Steps.png"/>
+          <p:cNvPr id="2" name="Picture 1" descr="image.png"/>
           <p:cNvPicPr>
             <a:picLocks noChangeAspect="1"/>
           </p:cNvPicPr>
@@ -3356,7 +3357,49 @@
       <p:grpSpPr/>
       <p:pic>
         <p:nvPicPr>
-          <p:cNvPr id="2" name="Picture 1" descr="12_Closing_And_Partners.png"/>
+          <p:cNvPr id="2" name="Picture 1" descr="image.png"/>
+          <p:cNvPicPr>
+            <a:picLocks noChangeAspect="1"/>
+          </p:cNvPicPr>
+          <p:nvPr/>
+        </p:nvPicPr>
+        <p:blipFill>
+          <a:blip r:embed="rId2"/>
+          <a:stretch>
+            <a:fillRect/>
+          </a:stretch>
+        </p:blipFill>
+        <p:spPr>
+          <a:xfrm>
+            <a:off x="0" y="0"/>
+            <a:ext cx="12191999" cy="6858000"/>
+          </a:xfrm>
+          <a:prstGeom prst="rect">
+            <a:avLst/>
+          </a:prstGeom>
+        </p:spPr>
+      </p:pic>
+    </p:spTree>
+  </p:cSld>
+  <p:clrMapOvr>
+    <a:masterClrMapping/>
+  </p:clrMapOvr>
+</p:sld>
+</file>
+
+<file path=ppt/slides/slide16.xml><?xml version="1.0" encoding="utf-8"?>
+<p:sld xmlns:a="http://schemas.openxmlformats.org/drawingml/2006/main" xmlns:p="http://schemas.openxmlformats.org/presentationml/2006/main" xmlns:r="http://schemas.openxmlformats.org/officeDocument/2006/relationships">
+  <p:cSld>
+    <p:spTree>
+      <p:nvGrpSpPr>
+        <p:cNvPr id="1" name=""/>
+        <p:cNvGrpSpPr/>
+        <p:nvPr/>
+      </p:nvGrpSpPr>
+      <p:grpSpPr/>
+      <p:pic>
+        <p:nvPicPr>
+          <p:cNvPr id="2" name="Picture 1" descr="image.png"/>
           <p:cNvPicPr>
             <a:picLocks noChangeAspect="1"/>
           </p:cNvPicPr>
@@ -3398,7 +3441,7 @@
       <p:grpSpPr/>
       <p:pic>
         <p:nvPicPr>
-          <p:cNvPr id="2" name="Picture 1" descr="Optional_A_Section_Title.png"/>
+          <p:cNvPr id="2" name="Picture 1" descr="image.png"/>
           <p:cNvPicPr>
             <a:picLocks noChangeAspect="1"/>
           </p:cNvPicPr>
@@ -3440,7 +3483,7 @@
       <p:grpSpPr/>
       <p:pic>
         <p:nvPicPr>
-          <p:cNvPr id="2" name="Picture 1" descr="02_The_Problem.png"/>
+          <p:cNvPr id="2" name="Picture 1" descr="image.png"/>
           <p:cNvPicPr>
             <a:picLocks noChangeAspect="1"/>
           </p:cNvPicPr>
@@ -3482,7 +3525,7 @@
       <p:grpSpPr/>
       <p:pic>
         <p:nvPicPr>
-          <p:cNvPr id="2" name="Picture 1" descr="Optional_C_Section_Title.png"/>
+          <p:cNvPr id="2" name="Picture 1" descr="image.png"/>
           <p:cNvPicPr>
             <a:picLocks noChangeAspect="1"/>
           </p:cNvPicPr>
@@ -3524,7 +3567,7 @@
       <p:grpSpPr/>
       <p:pic>
         <p:nvPicPr>
-          <p:cNvPr id="2" name="Picture 1" descr="03_Uninsured_Care.png"/>
+          <p:cNvPr id="2" name="Picture 1" descr="image.png"/>
           <p:cNvPicPr>
             <a:picLocks noChangeAspect="1"/>
           </p:cNvPicPr>
@@ -3566,7 +3609,7 @@
       <p:grpSpPr/>
       <p:pic>
         <p:nvPicPr>
-          <p:cNvPr id="2" name="Picture 1" descr="04_Outdoor_Plan.png"/>
+          <p:cNvPr id="2" name="Picture 1" descr="image.png"/>
           <p:cNvPicPr>
             <a:picLocks noChangeAspect="1"/>
           </p:cNvPicPr>
@@ -3608,7 +3651,7 @@
       <p:grpSpPr/>
       <p:pic>
         <p:nvPicPr>
-          <p:cNvPr id="2" name="Picture 1" descr="05_After_Tick_Bite.png"/>
+          <p:cNvPr id="2" name="Picture 1" descr="image.png"/>
           <p:cNvPicPr>
             <a:picLocks noChangeAspect="1"/>
           </p:cNvPicPr>
@@ -3650,7 +3693,7 @@
       <p:grpSpPr/>
       <p:pic>
         <p:nvPicPr>
-          <p:cNvPr id="2" name="Picture 1" descr="06_Visit_And_Language.png"/>
+          <p:cNvPr id="2" name="Picture 1" descr="image.png"/>
           <p:cNvPicPr>
             <a:picLocks noChangeAspect="1"/>
           </p:cNvPicPr>
@@ -3692,7 +3735,7 @@
       <p:grpSpPr/>
       <p:pic>
         <p:nvPicPr>
-          <p:cNvPr id="2" name="Picture 1" descr="07_Personal_Cost_Record.png"/>
+          <p:cNvPr id="2" name="Picture 1" descr="image.png"/>
           <p:cNvPicPr>
             <a:picLocks noChangeAspect="1"/>
           </p:cNvPicPr>

</xml_diff>